<commit_message>
Update A-Share Blast Lab / 2026-10-28 remove-5break-monitor
</commit_message>
<xml_diff>
--- a/assets/多空阶段简报_2026-10-28.pptx
+++ b/assets/多空阶段简报_2026-10-28.pptx
@@ -193,10 +193,10 @@
                 <c:formatCode>General</c:formatCode>
                 <c:ptCount val="4"/>
                 <c:pt idx="0">
-                  <c:v>2</c:v>
+                  <c:v>3</c:v>
                 </c:pt>
                 <c:pt idx="1">
-                  <c:v>14</c:v>
+                  <c:v>13</c:v>
                 </c:pt>
                 <c:pt idx="2">
                   <c:v>1</c:v>
@@ -334,25 +334,25 @@
                   <c:v>半导体芯片</c:v>
                 </c:pt>
                 <c:pt idx="2">
+                  <c:v>MLCC</c:v>
+                </c:pt>
+                <c:pt idx="3">
                   <c:v>机器人</c:v>
                 </c:pt>
-                <c:pt idx="3">
+                <c:pt idx="4">
                   <c:v>药</c:v>
-                </c:pt>
-                <c:pt idx="4">
-                  <c:v>MLCC</c:v>
                 </c:pt>
                 <c:pt idx="5">
                   <c:v>CPO</c:v>
                 </c:pt>
                 <c:pt idx="6">
-                  <c:v>互金证券</c:v>
+                  <c:v>半导体设备</c:v>
                 </c:pt>
                 <c:pt idx="7">
                   <c:v>半导体上游</c:v>
                 </c:pt>
                 <c:pt idx="8">
-                  <c:v>电力</c:v>
+                  <c:v>互金证券</c:v>
                 </c:pt>
               </c:strCache>
             </c:strRef>
@@ -367,28 +367,28 @@
                   <c:v>2</c:v>
                 </c:pt>
                 <c:pt idx="1">
+                  <c:v>6</c:v>
+                </c:pt>
+                <c:pt idx="2">
+                  <c:v>1</c:v>
+                </c:pt>
+                <c:pt idx="3">
                   <c:v>4</c:v>
                 </c:pt>
-                <c:pt idx="2">
-                  <c:v>4</c:v>
-                </c:pt>
-                <c:pt idx="3">
-                  <c:v>13</c:v>
-                </c:pt>
                 <c:pt idx="4">
-                  <c:v>2</c:v>
+                  <c:v>11</c:v>
                 </c:pt>
                 <c:pt idx="5">
                   <c:v>1</c:v>
                 </c:pt>
                 <c:pt idx="6">
-                  <c:v>4</c:v>
+                  <c:v>2</c:v>
                 </c:pt>
                 <c:pt idx="7">
                   <c:v>3</c:v>
                 </c:pt>
                 <c:pt idx="8">
-                  <c:v>0</c:v>
+                  <c:v>3</c:v>
                 </c:pt>
               </c:numCache>
             </c:numRef>
@@ -451,25 +451,25 @@
                   <c:v>半导体芯片</c:v>
                 </c:pt>
                 <c:pt idx="2">
+                  <c:v>MLCC</c:v>
+                </c:pt>
+                <c:pt idx="3">
                   <c:v>机器人</c:v>
                 </c:pt>
-                <c:pt idx="3">
+                <c:pt idx="4">
                   <c:v>药</c:v>
-                </c:pt>
-                <c:pt idx="4">
-                  <c:v>MLCC</c:v>
                 </c:pt>
                 <c:pt idx="5">
                   <c:v>CPO</c:v>
                 </c:pt>
                 <c:pt idx="6">
-                  <c:v>互金证券</c:v>
+                  <c:v>半导体设备</c:v>
                 </c:pt>
                 <c:pt idx="7">
                   <c:v>半导体上游</c:v>
                 </c:pt>
                 <c:pt idx="8">
-                  <c:v>电力</c:v>
+                  <c:v>互金证券</c:v>
                 </c:pt>
               </c:strCache>
             </c:strRef>
@@ -487,13 +487,13 @@
                   <c:v>3</c:v>
                 </c:pt>
                 <c:pt idx="2">
+                  <c:v>0</c:v>
+                </c:pt>
+                <c:pt idx="3">
                   <c:v>5</c:v>
                 </c:pt>
-                <c:pt idx="3">
+                <c:pt idx="4">
                   <c:v>2</c:v>
-                </c:pt>
-                <c:pt idx="4">
-                  <c:v>0</c:v>
                 </c:pt>
                 <c:pt idx="5">
                   <c:v>1</c:v>
@@ -505,7 +505,7 @@
                   <c:v>0</c:v>
                 </c:pt>
                 <c:pt idx="8">
-                  <c:v>1</c:v>
+                  <c:v>0</c:v>
                 </c:pt>
               </c:numCache>
             </c:numRef>
@@ -545,25 +545,25 @@
                   <c:v>半导体芯片</c:v>
                 </c:pt>
                 <c:pt idx="2">
+                  <c:v>MLCC</c:v>
+                </c:pt>
+                <c:pt idx="3">
                   <c:v>机器人</c:v>
                 </c:pt>
-                <c:pt idx="3">
+                <c:pt idx="4">
                   <c:v>药</c:v>
-                </c:pt>
-                <c:pt idx="4">
-                  <c:v>MLCC</c:v>
                 </c:pt>
                 <c:pt idx="5">
                   <c:v>CPO</c:v>
                 </c:pt>
                 <c:pt idx="6">
-                  <c:v>互金证券</c:v>
+                  <c:v>半导体设备</c:v>
                 </c:pt>
                 <c:pt idx="7">
                   <c:v>半导体上游</c:v>
                 </c:pt>
                 <c:pt idx="8">
-                  <c:v>电力</c:v>
+                  <c:v>互金证券</c:v>
                 </c:pt>
               </c:strCache>
             </c:strRef>
@@ -581,7 +581,7 @@
                   <c:v>1</c:v>
                 </c:pt>
                 <c:pt idx="2">
-                  <c:v>0</c:v>
+                  <c:v>1</c:v>
                 </c:pt>
                 <c:pt idx="3">
                   <c:v>0</c:v>
@@ -780,25 +780,25 @@
                   <c:v>半导体芯片</c:v>
                 </c:pt>
                 <c:pt idx="2">
+                  <c:v>MLCC</c:v>
+                </c:pt>
+                <c:pt idx="3">
                   <c:v>机器人</c:v>
                 </c:pt>
-                <c:pt idx="3">
+                <c:pt idx="4">
                   <c:v>药</c:v>
-                </c:pt>
-                <c:pt idx="4">
-                  <c:v>MLCC</c:v>
                 </c:pt>
                 <c:pt idx="5">
                   <c:v>CPO</c:v>
                 </c:pt>
                 <c:pt idx="6">
-                  <c:v>互金证券</c:v>
+                  <c:v>半导体设备</c:v>
                 </c:pt>
                 <c:pt idx="7">
                   <c:v>半导体上游</c:v>
                 </c:pt>
                 <c:pt idx="8">
-                  <c:v>电力</c:v>
+                  <c:v>互金证券</c:v>
                 </c:pt>
               </c:strCache>
             </c:strRef>
@@ -810,31 +810,31 @@
                 <c:formatCode>General</c:formatCode>
                 <c:ptCount val="9"/>
                 <c:pt idx="0">
-                  <c:v>45.5</c:v>
+                  <c:v>36.4</c:v>
                 </c:pt>
                 <c:pt idx="1">
-                  <c:v>26.0</c:v>
+                  <c:v>30.0</c:v>
                 </c:pt>
                 <c:pt idx="2">
+                  <c:v>18.8</c:v>
+                </c:pt>
+                <c:pt idx="3">
                   <c:v>15.7</c:v>
                 </c:pt>
-                <c:pt idx="3">
-                  <c:v>9.5</c:v>
-                </c:pt>
                 <c:pt idx="4">
-                  <c:v>6.2</c:v>
+                  <c:v>7.7</c:v>
                 </c:pt>
                 <c:pt idx="5">
                   <c:v>6.1</c:v>
                 </c:pt>
                 <c:pt idx="6">
-                  <c:v>4.9</c:v>
+                  <c:v>4.3</c:v>
                 </c:pt>
                 <c:pt idx="7">
                   <c:v>4.1</c:v>
                 </c:pt>
                 <c:pt idx="8">
-                  <c:v>3.2</c:v>
+                  <c:v>3.3</c:v>
                 </c:pt>
               </c:numCache>
             </c:numRef>
@@ -1351,7 +1351,7 @@
           <a:lstStyle/>
           <a:p>
             <a:r>
-              <a:t>当日共 17 个分组；改善 16、恶化 0。转多力度第一为 存储，强度 45.45。最强低位转势候选为 存储。</a:t>
+              <a:t>当日共 17 个分组；改善 16、恶化 0。转多力度第一为 存储，强度 36.36。最强低位转势候选为 半导体芯片。</a:t>
             </a:r>
           </a:p>
         </p:txBody>
@@ -1421,7 +1421,7 @@
           <a:lstStyle/>
           <a:p>
             <a:r>
-              <a:t>堆叠柱分别代表空转空转多、空转多转多、空直接转多。后两者更接近真实转多确认，空转空转多则是下一轮候选。最强低位转势候选：存储。</a:t>
+              <a:t>堆叠柱分别代表空转空转多、空转多转多、空直接转多。后两者更接近真实转多确认，空转空转多则是下一轮候选。最强低位转势候选：半导体芯片。</a:t>
             </a:r>
           </a:p>
         </p:txBody>
@@ -1561,7 +1561,7 @@
           <a:lstStyle/>
           <a:p>
             <a:r>
-              <a:t>次日先看空转多转多能否继续扩散，再检查空转空转多的蓄势池。反向压力主要来自：算力 转空 8 只｜商业航天 转空 7 只｜AI应用 转空 5 只｜药 转空 4 只。</a:t>
+              <a:t>次日先看空转多转多能否继续扩散，再检查空转空转多的蓄势池。反向压力主要来自：算力 转空 8 只｜商业航天 转空 6 只｜AI应用 转空 5 只｜药 转空 4 只。</a:t>
             </a:r>
           </a:p>
         </p:txBody>
@@ -5129,7 +5129,7 @@
                 </a:solidFill>
                 <a:latin typeface="Microsoft YaHei"/>
               </a:rPr>
-              <a:t>2</a:t>
+              <a:t>3</a:t>
             </a:r>
           </a:p>
         </p:txBody>
@@ -5603,7 +5603,7 @@
                 </a:solidFill>
                 <a:latin typeface="Microsoft YaHei"/>
               </a:rPr>
-              <a:t>强度 45.5</a:t>
+              <a:t>强度 36.4</a:t>
             </a:r>
           </a:p>
         </p:txBody>
@@ -5794,7 +5794,7 @@
                 </a:solidFill>
                 <a:latin typeface="Microsoft YaHei"/>
               </a:rPr>
-              <a:t>存储转多确认最强，存储以多占比 27.3% 成为最强低位转势候选，但同时提防算力、商业航天等反向转空。</a:t>
+              <a:t>存储转多确认最强，半导体芯片以多占比 18.0% 成为最强低位转势候选，但同时提防算力、商业航天等反向转空。</a:t>
             </a:r>
           </a:p>
         </p:txBody>
@@ -5923,7 +5923,7 @@
                 </a:solidFill>
                 <a:latin typeface="Microsoft YaHei"/>
               </a:rPr>
-              <a:t>存储</a:t>
+              <a:t>半导体芯片</a:t>
             </a:r>
           </a:p>
         </p:txBody>
@@ -6824,7 +6824,7 @@
                 </a:solidFill>
                 <a:latin typeface="Microsoft YaHei"/>
               </a:rPr>
-              <a:t>5 只｜多占比 81.4%</a:t>
+              <a:t>5 只｜多占比 80.0%</a:t>
             </a:r>
           </a:p>
         </p:txBody>
@@ -6953,7 +6953,7 @@
                 </a:solidFill>
                 <a:latin typeface="Microsoft YaHei"/>
               </a:rPr>
-              <a:t>存储</a:t>
+              <a:t>半导体芯片</a:t>
             </a:r>
           </a:p>
         </p:txBody>
@@ -6995,7 +6995,7 @@
                 </a:solidFill>
                 <a:latin typeface="Microsoft YaHei"/>
               </a:rPr>
-              <a:t>多占比 27.3%｜空转多→多 0 只｜空→空转多 2 只</a:t>
+              <a:t>多占比 18.0%｜空转多→多 3 只｜空→空转多 6 只</a:t>
             </a:r>
           </a:p>
         </p:txBody>
@@ -7421,7 +7421,7 @@
                 </a:solidFill>
                 <a:latin typeface="Microsoft YaHei"/>
               </a:rPr>
-              <a:t>存储  ·  45.5</a:t>
+              <a:t>存储  ·  36.4</a:t>
             </a:r>
           </a:p>
         </p:txBody>
@@ -7611,7 +7611,7 @@
                         </a:defRPr>
                       </a:pPr>
                       <a:r>
-                        <a:t>45.5</a:t>
+                        <a:t>36.4</a:t>
                       </a:r>
                     </a:p>
                   </a:txBody>
@@ -7709,7 +7709,7 @@
                         </a:defRPr>
                       </a:pPr>
                       <a:r>
-                        <a:t>26.0</a:t>
+                        <a:t>30.0</a:t>
                       </a:r>
                     </a:p>
                   </a:txBody>
@@ -7783,7 +7783,7 @@
                         </a:defRPr>
                       </a:pPr>
                       <a:r>
-                        <a:t>机器人</a:t>
+                        <a:t>MLCC</a:t>
                       </a:r>
                     </a:p>
                   </a:txBody>
@@ -7807,7 +7807,7 @@
                         </a:defRPr>
                       </a:pPr>
                       <a:r>
-                        <a:t>15.7</a:t>
+                        <a:t>18.8</a:t>
                       </a:r>
                     </a:p>
                   </a:txBody>
@@ -7831,7 +7831,7 @@
                         </a:defRPr>
                       </a:pPr>
                       <a:r>
-                        <a:t>5只</a:t>
+                        <a:t>0只</a:t>
                       </a:r>
                     </a:p>
                   </a:txBody>
@@ -7881,7 +7881,7 @@
                         </a:defRPr>
                       </a:pPr>
                       <a:r>
-                        <a:t>药</a:t>
+                        <a:t>机器人</a:t>
                       </a:r>
                     </a:p>
                   </a:txBody>
@@ -7905,7 +7905,7 @@
                         </a:defRPr>
                       </a:pPr>
                       <a:r>
-                        <a:t>9.5</a:t>
+                        <a:t>15.7</a:t>
                       </a:r>
                     </a:p>
                   </a:txBody>
@@ -7929,7 +7929,7 @@
                         </a:defRPr>
                       </a:pPr>
                       <a:r>
-                        <a:t>2只</a:t>
+                        <a:t>5只</a:t>
                       </a:r>
                     </a:p>
                   </a:txBody>
@@ -7979,7 +7979,7 @@
                         </a:defRPr>
                       </a:pPr>
                       <a:r>
-                        <a:t>MLCC</a:t>
+                        <a:t>药</a:t>
                       </a:r>
                     </a:p>
                   </a:txBody>
@@ -8003,7 +8003,7 @@
                         </a:defRPr>
                       </a:pPr>
                       <a:r>
-                        <a:t>6.2</a:t>
+                        <a:t>7.7</a:t>
                       </a:r>
                     </a:p>
                   </a:txBody>
@@ -8027,7 +8027,7 @@
                         </a:defRPr>
                       </a:pPr>
                       <a:r>
-                        <a:t>0只</a:t>
+                        <a:t>2只</a:t>
                       </a:r>
                     </a:p>
                   </a:txBody>
@@ -8630,7 +8630,7 @@
                 </a:solidFill>
                 <a:latin typeface="Microsoft YaHei"/>
               </a:rPr>
-              <a:t>45.5 分</a:t>
+              <a:t>36.4 分</a:t>
             </a:r>
           </a:p>
         </p:txBody>
@@ -8672,7 +8672,7 @@
                 </a:solidFill>
                 <a:latin typeface="Microsoft YaHei"/>
               </a:rPr>
-              <a:t>空→多跳级 1 只；空→空转多蓄势 2 只</a:t>
+              <a:t>空→多跳级 1 只；空→空转多蓄势 2 只；反向转空 1 只</a:t>
             </a:r>
           </a:p>
         </p:txBody>
@@ -8888,7 +8888,7 @@
                 </a:solidFill>
                 <a:latin typeface="Microsoft YaHei"/>
               </a:rPr>
-              <a:t>26.0 分</a:t>
+              <a:t>30.0 分</a:t>
             </a:r>
           </a:p>
         </p:txBody>
@@ -8972,7 +8972,7 @@
                 </a:solidFill>
                 <a:latin typeface="Microsoft YaHei"/>
               </a:rPr>
-              <a:t>空转多→多 3 只｜空→空转多 4 只｜多占比 20.0%</a:t>
+              <a:t>空转多→多 3 只｜空→空转多 6 只｜多占比 18.0%</a:t>
             </a:r>
           </a:p>
         </p:txBody>
@@ -9039,7 +9039,7 @@
             <a:avLst/>
           </a:prstGeom>
           <a:solidFill>
-            <a:srgbClr val="E88B36"/>
+            <a:srgbClr val="D34347"/>
           </a:solidFill>
           <a:ln>
             <a:noFill/>
@@ -9104,7 +9104,7 @@
                 </a:solidFill>
                 <a:latin typeface="Microsoft YaHei"/>
               </a:rPr>
-              <a:t>机器人</a:t>
+              <a:t>MLCC</a:t>
             </a:r>
           </a:p>
         </p:txBody>
@@ -9142,11 +9142,11 @@
             <a:r>
               <a:rPr sz="950" b="1" i="0">
                 <a:solidFill>
-                  <a:srgbClr val="E88B36"/>
+                  <a:srgbClr val="D34347"/>
                 </a:solidFill>
                 <a:latin typeface="Microsoft YaHei"/>
               </a:rPr>
-              <a:t>15.7 分</a:t>
+              <a:t>18.8 分</a:t>
             </a:r>
           </a:p>
         </p:txBody>
@@ -9188,7 +9188,7 @@
                 </a:solidFill>
                 <a:latin typeface="Microsoft YaHei"/>
               </a:rPr>
-              <a:t>空转多→多 2→5；反向转空 3 只</a:t>
+              <a:t>空→多跳级 1 只；空→空转多蓄势 1 只；反向转空 1 只</a:t>
             </a:r>
           </a:p>
         </p:txBody>
@@ -9230,7 +9230,7 @@
                 </a:solidFill>
                 <a:latin typeface="Microsoft YaHei"/>
               </a:rPr>
-              <a:t>空转多→多 5 只｜空→空转多 4 只｜多占比 81.4%</a:t>
+              <a:t>空转多→多 0 只｜空→空转多 1 只｜多占比 6.2%</a:t>
             </a:r>
           </a:p>
         </p:txBody>
@@ -9362,7 +9362,7 @@
                 </a:solidFill>
                 <a:latin typeface="Microsoft YaHei"/>
               </a:rPr>
-              <a:t>药</a:t>
+              <a:t>机器人</a:t>
             </a:r>
           </a:p>
         </p:txBody>
@@ -9404,7 +9404,7 @@
                 </a:solidFill>
                 <a:latin typeface="Microsoft YaHei"/>
               </a:rPr>
-              <a:t>9.5 分</a:t>
+              <a:t>15.7 分</a:t>
             </a:r>
           </a:p>
         </p:txBody>
@@ -9446,7 +9446,7 @@
                 </a:solidFill>
                 <a:latin typeface="Microsoft YaHei"/>
               </a:rPr>
-              <a:t>空转多→多 0→2；反向转空 4 只</a:t>
+              <a:t>空转多→多 2→5；反向转空 3 只</a:t>
             </a:r>
           </a:p>
         </p:txBody>
@@ -9488,7 +9488,7 @@
                 </a:solidFill>
                 <a:latin typeface="Microsoft YaHei"/>
               </a:rPr>
-              <a:t>空转多→多 2 只｜空→空转多 13 只｜多占比 11.5%</a:t>
+              <a:t>空转多→多 5 只｜空→空转多 4 只｜多占比 80.0%</a:t>
             </a:r>
           </a:p>
         </p:txBody>
@@ -9555,7 +9555,7 @@
             <a:avLst/>
           </a:prstGeom>
           <a:solidFill>
-            <a:srgbClr val="F0B744"/>
+            <a:srgbClr val="E88B36"/>
           </a:solidFill>
           <a:ln>
             <a:noFill/>
@@ -9620,7 +9620,7 @@
                 </a:solidFill>
                 <a:latin typeface="Microsoft YaHei"/>
               </a:rPr>
-              <a:t>MLCC</a:t>
+              <a:t>药</a:t>
             </a:r>
           </a:p>
         </p:txBody>
@@ -9658,11 +9658,11 @@
             <a:r>
               <a:rPr sz="950" b="1" i="0">
                 <a:solidFill>
-                  <a:srgbClr val="F0B744"/>
+                  <a:srgbClr val="E88B36"/>
                 </a:solidFill>
                 <a:latin typeface="Microsoft YaHei"/>
               </a:rPr>
-              <a:t>6.2 分</a:t>
+              <a:t>7.7 分</a:t>
             </a:r>
           </a:p>
         </p:txBody>
@@ -9704,7 +9704,7 @@
                 </a:solidFill>
                 <a:latin typeface="Microsoft YaHei"/>
               </a:rPr>
-              <a:t>空→空转多蓄势 2 只；反向转空 1 只</a:t>
+              <a:t>空转多→多 0→2；反向转空 4 只</a:t>
             </a:r>
           </a:p>
         </p:txBody>
@@ -9746,7 +9746,7 @@
                 </a:solidFill>
                 <a:latin typeface="Microsoft YaHei"/>
               </a:rPr>
-              <a:t>空转多→多 0 只｜空→空转多 2 只｜多占比 0.0%</a:t>
+              <a:t>空转多→多 2 只｜空→空转多 11 只｜多占比 10.9%</a:t>
             </a:r>
           </a:p>
         </p:txBody>
@@ -10133,7 +10133,7 @@
                 </a:solidFill>
                 <a:latin typeface="Microsoft YaHei"/>
               </a:rPr>
-              <a:t>算力 转空 8 只｜商业航天 转空 7 只｜AI应用 转空 5 只｜药 转空 4 只</a:t>
+              <a:t>算力 转空 8 只｜商业航天 转空 6 只｜AI应用 转空 5 只｜药 转空 4 只</a:t>
             </a:r>
           </a:p>
         </p:txBody>

</xml_diff>